<commit_message>
try DT25 on 24 data, refine overwrite_log_dir flag, add final_score metric
</commit_message>
<xml_diff>
--- a/documents/presentations/Jannis_Meyer_Presentation_01_06_2026.pptx
+++ b/documents/presentations/Jannis_Meyer_Presentation_01_06_2026.pptx
@@ -1695,7 +1695,7 @@
           <a:p>
             <a:fld id="{8664C608-40B1-4030-A28D-5B74BC98ADCE}" type="datetimeFigureOut">
               <a:rPr lang="en-US" dirty="0"/>
-              <a:t>5/29/2026</a:t>
+              <a:t>5/31/2026</a:t>
             </a:fld>
             <a:endParaRPr lang="en-US" dirty="0"/>
           </a:p>
@@ -6574,7 +6574,7 @@
         </p:spPr>
         <p:txBody>
           <a:bodyPr vert="horz" lIns="91440" tIns="45720" rIns="91440" bIns="45720" rtlCol="0" anchor="t">
-            <a:normAutofit/>
+            <a:normAutofit lnSpcReduction="10000"/>
           </a:bodyPr>
           <a:lstStyle/>
           <a:p>
@@ -6590,15 +6590,25 @@
             </a:r>
           </a:p>
           <a:p>
-            <a:pPr marL="0" indent="0">
+            <a:pPr>
               <a:buClr>
                 <a:srgbClr val="9E3611"/>
               </a:buClr>
-              <a:buNone/>
             </a:pPr>
             <a:r>
               <a:rPr lang="en-US" sz="2000" b="0" dirty="0"/>
               <a:t>Error between estimated position and GT of final frame</a:t>
+            </a:r>
+          </a:p>
+          <a:p>
+            <a:pPr>
+              <a:buClr>
+                <a:srgbClr val="9E3611"/>
+              </a:buClr>
+            </a:pPr>
+            <a:r>
+              <a:rPr lang="en-US" sz="2000" b="0" dirty="0"/>
+              <a:t>Common error metric in 3D US reconstruction</a:t>
             </a:r>
           </a:p>
           <a:p>
@@ -6623,15 +6633,25 @@
             </a:r>
           </a:p>
           <a:p>
-            <a:pPr marL="0" indent="0">
+            <a:pPr>
               <a:buClr>
                 <a:srgbClr val="9E3611"/>
               </a:buClr>
-              <a:buNone/>
             </a:pPr>
             <a:r>
               <a:rPr lang="en-US" sz="2000" b="0" dirty="0"/>
               <a:t>“Average point error between the true position and the fully reconstructed trajectory estimate at each timestep”</a:t>
+            </a:r>
+          </a:p>
+          <a:p>
+            <a:pPr>
+              <a:buClr>
+                <a:srgbClr val="9E3611"/>
+              </a:buClr>
+            </a:pPr>
+            <a:r>
+              <a:rPr lang="en-US" sz="2000" b="0" dirty="0"/>
+              <a:t>Used in TUSREC challenge to evaluate model</a:t>
             </a:r>
           </a:p>
           <a:p>
@@ -6704,7 +6724,7 @@
         <p:spPr>
           <a:xfrm>
             <a:off x="179512" y="4704588"/>
-            <a:ext cx="2508444" cy="276999"/>
+            <a:ext cx="6182013" cy="461665"/>
           </a:xfrm>
           <a:prstGeom prst="rect">
             <a:avLst/>
@@ -6718,9 +6738,25 @@
           <a:lstStyle/>
           <a:p>
             <a:r>
+              <a:rPr lang="en-US" sz="1200" dirty="0">
+                <a:hlinkClick r:id="rId3"/>
+              </a:rPr>
+              <a:t>https://arxiv.org/pdf/2509.09530</a:t>
+            </a:r>
+            <a:r>
               <a:rPr lang="en-US" sz="1200" dirty="0"/>
-              <a:t>https://arxiv.org/pdf/2509.09530</a:t>
-            </a:r>
+              <a:t>, </a:t>
+            </a:r>
+            <a:r>
+              <a:rPr lang="en-US" sz="1200" dirty="0">
+                <a:hlinkClick r:id="rId4"/>
+              </a:rPr>
+              <a:t>https://github-pages.ucl.ac.uk/tus-rec-challenge/</a:t>
+            </a:r>
+            <a:endParaRPr lang="en-US" sz="1200" dirty="0"/>
+          </a:p>
+          <a:p>
+            <a:endParaRPr lang="en-US" sz="1200" dirty="0"/>
           </a:p>
         </p:txBody>
       </p:sp>
@@ -6845,14 +6881,14 @@
           <p:nvPr>
             <p:extLst>
               <p:ext uri="{D42A27DB-BD31-4B8C-83A1-F6EECF244321}">
-                <p14:modId xmlns:p14="http://schemas.microsoft.com/office/powerpoint/2010/main" val="818402404"/>
+                <p14:modId xmlns:p14="http://schemas.microsoft.com/office/powerpoint/2010/main" val="1626087587"/>
               </p:ext>
             </p:extLst>
           </p:nvPr>
         </p:nvGraphicFramePr>
         <p:xfrm>
           <a:off x="229947" y="699542"/>
-          <a:ext cx="8684105" cy="3950614"/>
+          <a:ext cx="8684105" cy="3888433"/>
         </p:xfrm>
         <a:graphic>
           <a:graphicData uri="http://schemas.openxmlformats.org/drawingml/2006/table">
@@ -7006,6 +7042,16 @@
                         <a:t>TUSREC24 Validation Data</a:t>
                       </a:r>
                     </a:p>
+                    <a:p>
+                      <a:r>
+                        <a:rPr lang="en-US" b="1" dirty="0">
+                          <a:solidFill>
+                            <a:schemeClr val="bg1"/>
+                          </a:solidFill>
+                        </a:rPr>
+                        <a:t>(72 scans)</a:t>
+                      </a:r>
+                    </a:p>
                   </a:txBody>
                   <a:tcPr>
                     <a:solidFill>
@@ -7020,7 +7066,7 @@
                     <a:p>
                       <a:r>
                         <a:rPr lang="en-US" dirty="0"/>
-                        <a:t>AVG FDR: 5.1%</a:t>
+                        <a:t>FDR: 5.1%</a:t>
                       </a:r>
                     </a:p>
                     <a:p>
@@ -7029,7 +7075,7 @@
                     <a:p>
                       <a:r>
                         <a:rPr lang="en-US" dirty="0"/>
-                        <a:t>AVG GPE: 4.9mm</a:t>
+                        <a:t>GPE: 4.9mm</a:t>
                       </a:r>
                     </a:p>
                     <a:p>
@@ -7048,7 +7094,40 @@
                     <a:p>
                       <a:r>
                         <a:rPr lang="en-US" dirty="0"/>
-                        <a:t>/</a:t>
+                        <a:t>FDR: </a:t>
+                      </a:r>
+                      <a:r>
+                        <a:rPr kumimoji="1" lang="en-US" sz="1350" b="0" kern="1200" dirty="0">
+                          <a:solidFill>
+                            <a:schemeClr val="dk1"/>
+                          </a:solidFill>
+                          <a:effectLst/>
+                          <a:latin typeface="+mn-lt"/>
+                          <a:ea typeface="+mn-ea"/>
+                          <a:cs typeface="+mn-cs"/>
+                        </a:rPr>
+                        <a:t>28.54%</a:t>
+                      </a:r>
+                    </a:p>
+                    <a:p>
+                      <a:endParaRPr lang="en-US" dirty="0"/>
+                    </a:p>
+                    <a:p>
+                      <a:r>
+                        <a:rPr lang="en-US" dirty="0"/>
+                        <a:t>AVG GPE: </a:t>
+                      </a:r>
+                      <a:r>
+                        <a:rPr kumimoji="1" lang="en-US" sz="1350" b="0" kern="1200" dirty="0">
+                          <a:solidFill>
+                            <a:schemeClr val="dk1"/>
+                          </a:solidFill>
+                          <a:effectLst/>
+                          <a:latin typeface="+mn-lt"/>
+                          <a:ea typeface="+mn-ea"/>
+                          <a:cs typeface="+mn-cs"/>
+                        </a:rPr>
+                        <a:t>24.79mm</a:t>
                       </a:r>
                     </a:p>
                   </a:txBody>
@@ -7118,6 +7197,46 @@
                         <a:t>TUSREC25 Validation Data</a:t>
                       </a:r>
                     </a:p>
+                    <a:p>
+                      <a:pPr marL="0" marR="0" lvl="0" indent="0" algn="l" defTabSz="685800" rtl="0" eaLnBrk="1" fontAlgn="auto" latinLnBrk="0" hangingPunct="1">
+                        <a:lnSpc>
+                          <a:spcPct val="100000"/>
+                        </a:lnSpc>
+                        <a:spcBef>
+                          <a:spcPts val="0"/>
+                        </a:spcBef>
+                        <a:spcAft>
+                          <a:spcPts val="0"/>
+                        </a:spcAft>
+                        <a:buClrTx/>
+                        <a:buSzTx/>
+                        <a:buFontTx/>
+                        <a:buNone/>
+                        <a:tabLst/>
+                        <a:defRPr/>
+                      </a:pPr>
+                      <a:r>
+                        <a:rPr lang="en-US" b="1" dirty="0">
+                          <a:solidFill>
+                            <a:schemeClr val="bg1"/>
+                          </a:solidFill>
+                        </a:rPr>
+                        <a:t>(</a:t>
+                      </a:r>
+                      <a:r>
+                        <a:rPr lang="en-US" b="1">
+                          <a:solidFill>
+                            <a:schemeClr val="bg1"/>
+                          </a:solidFill>
+                        </a:rPr>
+                        <a:t>six scans)</a:t>
+                      </a:r>
+                      <a:endParaRPr lang="en-US" b="1" dirty="0">
+                        <a:solidFill>
+                          <a:schemeClr val="bg1"/>
+                        </a:solidFill>
+                      </a:endParaRPr>
+                    </a:p>
                   </a:txBody>
                   <a:tcPr>
                     <a:solidFill>
@@ -7140,21 +7259,7 @@
                           <a:ea typeface="+mn-ea"/>
                           <a:cs typeface="+mn-cs"/>
                         </a:rPr>
-                        <a:t>AVG FDR:</a:t>
-                      </a:r>
-                    </a:p>
-                    <a:p>
-                      <a:r>
-                        <a:rPr kumimoji="1" lang="en-US" sz="1350" b="0" kern="1200">
-                          <a:solidFill>
-                            <a:schemeClr val="dk1"/>
-                          </a:solidFill>
-                          <a:effectLst/>
-                          <a:latin typeface="+mn-lt"/>
-                          <a:ea typeface="+mn-ea"/>
-                          <a:cs typeface="+mn-cs"/>
-                        </a:rPr>
-                        <a:t>488.77%</a:t>
+                        <a:t>FDR: 488.77%</a:t>
                       </a:r>
                     </a:p>
                     <a:p>
@@ -7179,21 +7284,7 @@
                           <a:ea typeface="+mn-ea"/>
                           <a:cs typeface="+mn-cs"/>
                         </a:rPr>
-                        <a:t>AVG GPE:</a:t>
-                      </a:r>
-                    </a:p>
-                    <a:p>
-                      <a:r>
-                        <a:rPr kumimoji="1" lang="en-US" sz="1350" b="0" kern="1200" dirty="0">
-                          <a:solidFill>
-                            <a:schemeClr val="dk1"/>
-                          </a:solidFill>
-                          <a:effectLst/>
-                          <a:latin typeface="+mn-lt"/>
-                          <a:ea typeface="+mn-ea"/>
-                          <a:cs typeface="+mn-cs"/>
-                        </a:rPr>
-                        <a:t>56.53mm</a:t>
+                        <a:t>GPE: 56.53mm</a:t>
                       </a:r>
                     </a:p>
                   </a:txBody>
@@ -7206,13 +7297,7 @@
                     <a:p>
                       <a:r>
                         <a:rPr lang="en-US" dirty="0"/>
-                        <a:t>AVG FDR: 72.9%</a:t>
-                      </a:r>
-                    </a:p>
-                    <a:p>
-                      <a:r>
-                        <a:rPr lang="en-US" dirty="0"/>
-                        <a:t>(extremely bad!)</a:t>
+                        <a:t>FDR: 72.9%</a:t>
                       </a:r>
                     </a:p>
                     <a:p>
@@ -7221,7 +7306,7 @@
                     <a:p>
                       <a:r>
                         <a:rPr lang="en-US" dirty="0"/>
-                        <a:t>AVG GPE: 9.1mm</a:t>
+                        <a:t>GPE: 9.1mm</a:t>
                       </a:r>
                     </a:p>
                     <a:p>
@@ -7272,6 +7357,44 @@
           </a:graphicData>
         </a:graphic>
       </p:graphicFrame>
+      <p:sp>
+        <p:nvSpPr>
+          <p:cNvPr id="2" name="TextBox 1">
+            <a:extLst>
+              <a:ext uri="{FF2B5EF4-FFF2-40B4-BE49-F238E27FC236}">
+                <a16:creationId xmlns:a16="http://schemas.microsoft.com/office/drawing/2014/main" id="{7A594B44-DBCF-6B17-6075-4E33289543B8}"/>
+              </a:ext>
+            </a:extLst>
+          </p:cNvPr>
+          <p:cNvSpPr txBox="1"/>
+          <p:nvPr/>
+        </p:nvSpPr>
+        <p:spPr>
+          <a:xfrm>
+            <a:off x="179512" y="4704588"/>
+            <a:ext cx="2901948" cy="461665"/>
+          </a:xfrm>
+          <a:prstGeom prst="rect">
+            <a:avLst/>
+          </a:prstGeom>
+          <a:noFill/>
+        </p:spPr>
+        <p:txBody>
+          <a:bodyPr wrap="none" rtlCol="0">
+            <a:spAutoFit/>
+          </a:bodyPr>
+          <a:lstStyle/>
+          <a:p>
+            <a:r>
+              <a:rPr lang="en-US" sz="1200" dirty="0"/>
+              <a:t>*FDR and GPE averaged over all scans</a:t>
+            </a:r>
+          </a:p>
+          <a:p>
+            <a:endParaRPr lang="en-US" sz="1200" dirty="0"/>
+          </a:p>
+        </p:txBody>
+      </p:sp>
     </p:spTree>
     <p:extLst>
       <p:ext uri="{BB962C8B-B14F-4D97-AF65-F5344CB8AC3E}">
@@ -7517,7 +7640,7 @@
         <p:spPr>
           <a:xfrm>
             <a:off x="182430" y="4694682"/>
-            <a:ext cx="3710246" cy="276999"/>
+            <a:ext cx="3793603" cy="276999"/>
           </a:xfrm>
           <a:prstGeom prst="rect">
             <a:avLst/>
@@ -7531,9 +7654,12 @@
           <a:lstStyle/>
           <a:p>
             <a:r>
-              <a:rPr lang="en-US" sz="1200" dirty="0"/>
+              <a:rPr lang="en-US" sz="1200" dirty="0">
+                <a:hlinkClick r:id="rId3"/>
+              </a:rPr>
               <a:t>https://github-pages.ucl.ac.uk/tus-rec-challenge/</a:t>
             </a:r>
+            <a:endParaRPr lang="en-US" sz="1200" dirty="0"/>
           </a:p>
         </p:txBody>
       </p:sp>
@@ -8534,6 +8660,15 @@
 </file>
 
 <file path=customXml/item2.xml><?xml version="1.0" encoding="utf-8"?>
+<?mso-contentType ?>
+<FormTemplates xmlns="http://schemas.microsoft.com/sharepoint/v3/contenttype/forms">
+  <Display>DocumentLibraryForm</Display>
+  <Edit>DocumentLibraryForm</Edit>
+  <New>DocumentLibraryForm</New>
+</FormTemplates>
+</file>
+
+<file path=customXml/item3.xml><?xml version="1.0" encoding="utf-8"?>
 <p:properties xmlns:p="http://schemas.microsoft.com/office/2006/metadata/properties" xmlns:xsi="http://www.w3.org/2001/XMLSchema-instance" xmlns:pc="http://schemas.microsoft.com/office/infopath/2007/PartnerControls">
   <documentManagement>
     <TaxCatchAll xmlns="bbdc8989-56fb-4b1d-a38b-166581c893ff" xsi:nil="true"/>
@@ -8594,15 +8729,6 @@
 </p:properties>
 </file>
 
-<file path=customXml/item3.xml><?xml version="1.0" encoding="utf-8"?>
-<?mso-contentType ?>
-<FormTemplates xmlns="http://schemas.microsoft.com/sharepoint/v3/contenttype/forms">
-  <Display>DocumentLibraryForm</Display>
-  <Edit>DocumentLibraryForm</Edit>
-  <New>DocumentLibraryForm</New>
-</FormTemplates>
-</file>
-
 <file path=customXml/itemProps1.xml><?xml version="1.0" encoding="utf-8"?>
 <ds:datastoreItem xmlns:ds="http://schemas.openxmlformats.org/officeDocument/2006/customXml" ds:itemID="{F2D09310-C45E-477D-9B05-494A1C2D1783}">
   <ds:schemaRefs>
@@ -8623,6 +8749,14 @@
 </file>
 
 <file path=customXml/itemProps2.xml><?xml version="1.0" encoding="utf-8"?>
+<ds:datastoreItem xmlns:ds="http://schemas.openxmlformats.org/officeDocument/2006/customXml" ds:itemID="{0A8BCAEC-5EDD-4F8B-8062-E645C37DABB6}">
+  <ds:schemaRefs>
+    <ds:schemaRef ds:uri="http://schemas.microsoft.com/sharepoint/v3/contenttype/forms"/>
+  </ds:schemaRefs>
+</ds:datastoreItem>
+</file>
+
+<file path=customXml/itemProps3.xml><?xml version="1.0" encoding="utf-8"?>
 <ds:datastoreItem xmlns:ds="http://schemas.openxmlformats.org/officeDocument/2006/customXml" ds:itemID="{726A834E-B1B5-46FD-BC6A-86110B9E53A8}">
   <ds:schemaRefs>
     <ds:schemaRef ds:uri="f61654bb-b7fc-45ad-85e3-d08f7c4a7ee2"/>
@@ -8637,12 +8771,4 @@
     <ds:schemaRef ds:uri="http://schemas.microsoft.com/office/2006/metadata/properties"/>
   </ds:schemaRefs>
 </ds:datastoreItem>
-</file>
-
-<file path=customXml/itemProps3.xml><?xml version="1.0" encoding="utf-8"?>
-<ds:datastoreItem xmlns:ds="http://schemas.openxmlformats.org/officeDocument/2006/customXml" ds:itemID="{0A8BCAEC-5EDD-4F8B-8062-E645C37DABB6}">
-  <ds:schemaRefs>
-    <ds:schemaRef ds:uri="http://schemas.microsoft.com/sharepoint/v3/contenttype/forms"/>
-  </ds:schemaRefs>
-</ds:datastoreItem>
 </file>
</xml_diff>

<commit_message>
evaluate DT25 on 25 data with base pgo
</commit_message>
<xml_diff>
--- a/documents/presentations/Jannis_Meyer_Presentation_01_06_2026.pptx
+++ b/documents/presentations/Jannis_Meyer_Presentation_01_06_2026.pptx
@@ -5,15 +5,16 @@
     <p:sldMasterId id="2284242785" r:id="rId4"/>
   </p:sldMasterIdLst>
   <p:notesMasterIdLst>
-    <p:notesMasterId r:id="rId11"/>
+    <p:notesMasterId r:id="rId12"/>
   </p:notesMasterIdLst>
   <p:sldIdLst>
     <p:sldId id="256" r:id="rId5"/>
     <p:sldId id="281" r:id="rId6"/>
     <p:sldId id="282" r:id="rId7"/>
     <p:sldId id="284" r:id="rId8"/>
-    <p:sldId id="283" r:id="rId9"/>
-    <p:sldId id="285" r:id="rId10"/>
+    <p:sldId id="286" r:id="rId9"/>
+    <p:sldId id="283" r:id="rId10"/>
+    <p:sldId id="285" r:id="rId11"/>
   </p:sldIdLst>
   <p:sldSz cx="9144000" cy="5143500" type="screen16x9"/>
   <p:notesSz cx="9144000" cy="6858000"/>
@@ -529,6 +530,107 @@
         <p:cNvPr id="1" name="">
           <a:extLst>
             <a:ext uri="{FF2B5EF4-FFF2-40B4-BE49-F238E27FC236}">
+              <a16:creationId xmlns:a16="http://schemas.microsoft.com/office/drawing/2014/main" id="{F4316842-0B0E-91C8-7F35-B356EFFB7314}"/>
+            </a:ext>
+          </a:extLst>
+        </p:cNvPr>
+        <p:cNvGrpSpPr/>
+        <p:nvPr/>
+      </p:nvGrpSpPr>
+      <p:grpSpPr>
+        <a:xfrm>
+          <a:off x="0" y="0"/>
+          <a:ext cx="0" cy="0"/>
+          <a:chOff x="0" y="0"/>
+          <a:chExt cx="0" cy="0"/>
+        </a:xfrm>
+      </p:grpSpPr>
+      <p:sp>
+        <p:nvSpPr>
+          <p:cNvPr id="2" name="Slide Image Placeholder 1">
+            <a:extLst>
+              <a:ext uri="{FF2B5EF4-FFF2-40B4-BE49-F238E27FC236}">
+                <a16:creationId xmlns:a16="http://schemas.microsoft.com/office/drawing/2014/main" id="{8D7FB22F-F84F-D3D2-EF9C-3CF06ED1624C}"/>
+              </a:ext>
+            </a:extLst>
+          </p:cNvPr>
+          <p:cNvSpPr>
+            <a:spLocks noGrp="1" noRot="1" noChangeAspect="1"/>
+          </p:cNvSpPr>
+          <p:nvPr>
+            <p:ph type="sldImg"/>
+          </p:nvPr>
+        </p:nvSpPr>
+        <p:spPr>
+          <a:xfrm>
+            <a:off x="2514600" y="857250"/>
+            <a:ext cx="4114800" cy="2314575"/>
+          </a:xfrm>
+          <a:prstGeom prst="rect">
+            <a:avLst/>
+          </a:prstGeom>
+          <a:noFill/>
+          <a:ln w="12700">
+            <a:solidFill>
+              <a:prstClr val="black"/>
+            </a:solidFill>
+          </a:ln>
+        </p:spPr>
+      </p:sp>
+      <p:sp>
+        <p:nvSpPr>
+          <p:cNvPr id="3" name="Notes Placeholder 2">
+            <a:extLst>
+              <a:ext uri="{FF2B5EF4-FFF2-40B4-BE49-F238E27FC236}">
+                <a16:creationId xmlns:a16="http://schemas.microsoft.com/office/drawing/2014/main" id="{DAD00DD1-C3C9-F066-CCEC-C1128C44AC7F}"/>
+              </a:ext>
+            </a:extLst>
+          </p:cNvPr>
+          <p:cNvSpPr>
+            <a:spLocks noGrp="1"/>
+          </p:cNvSpPr>
+          <p:nvPr>
+            <p:ph type="body" idx="1"/>
+          </p:nvPr>
+        </p:nvSpPr>
+        <p:spPr>
+          <a:xfrm>
+            <a:off x="914400" y="3300413"/>
+            <a:ext cx="7315200" cy="2700337"/>
+          </a:xfrm>
+          <a:prstGeom prst="rect">
+            <a:avLst/>
+          </a:prstGeom>
+        </p:spPr>
+        <p:txBody>
+          <a:bodyPr/>
+          <a:lstStyle/>
+          <a:p>
+            <a:endParaRPr lang="en-US" dirty="0"/>
+          </a:p>
+        </p:txBody>
+      </p:sp>
+    </p:spTree>
+    <p:extLst>
+      <p:ext uri="{BB962C8B-B14F-4D97-AF65-F5344CB8AC3E}">
+        <p14:creationId xmlns:p14="http://schemas.microsoft.com/office/powerpoint/2010/main" val="2294665136"/>
+      </p:ext>
+    </p:extLst>
+  </p:cSld>
+  <p:clrMapOvr>
+    <a:masterClrMapping/>
+  </p:clrMapOvr>
+</p:notes>
+</file>
+
+<file path=ppt/notesSlides/notesSlide5.xml><?xml version="1.0" encoding="utf-8"?>
+<p:notes xmlns:a="http://schemas.openxmlformats.org/drawingml/2006/main" xmlns:r="http://schemas.openxmlformats.org/officeDocument/2006/relationships" xmlns:p="http://schemas.openxmlformats.org/presentationml/2006/main">
+  <p:cSld>
+    <p:spTree>
+      <p:nvGrpSpPr>
+        <p:cNvPr id="1" name="">
+          <a:extLst>
+            <a:ext uri="{FF2B5EF4-FFF2-40B4-BE49-F238E27FC236}">
               <a16:creationId xmlns:a16="http://schemas.microsoft.com/office/drawing/2014/main" id="{61282EDE-AC15-F05A-2039-AFB22CC1A359}"/>
             </a:ext>
           </a:extLst>
@@ -622,7 +724,7 @@
 </p:notes>
 </file>
 
-<file path=ppt/notesSlides/notesSlide5.xml><?xml version="1.0" encoding="utf-8"?>
+<file path=ppt/notesSlides/notesSlide6.xml><?xml version="1.0" encoding="utf-8"?>
 <p:notes xmlns:a="http://schemas.openxmlformats.org/drawingml/2006/main" xmlns:r="http://schemas.openxmlformats.org/officeDocument/2006/relationships" xmlns:p="http://schemas.openxmlformats.org/presentationml/2006/main">
   <p:cSld>
     <p:spTree>
@@ -6574,7 +6676,7 @@
         </p:spPr>
         <p:txBody>
           <a:bodyPr vert="horz" lIns="91440" tIns="45720" rIns="91440" bIns="45720" rtlCol="0" anchor="t">
-            <a:normAutofit lnSpcReduction="10000"/>
+            <a:normAutofit fontScale="92500" lnSpcReduction="10000"/>
           </a:bodyPr>
           <a:lstStyle/>
           <a:p>
@@ -6598,6 +6700,17 @@
             <a:r>
               <a:rPr lang="en-US" sz="2000" b="0" dirty="0"/>
               <a:t>Error between estimated position and GT of final frame</a:t>
+            </a:r>
+          </a:p>
+          <a:p>
+            <a:pPr>
+              <a:buClr>
+                <a:srgbClr val="9E3611"/>
+              </a:buClr>
+            </a:pPr>
+            <a:r>
+              <a:rPr lang="en-US" sz="2000" b="0" dirty="0"/>
+              <a:t>Only translation</a:t>
             </a:r>
           </a:p>
           <a:p>
@@ -6651,7 +6764,15 @@
             </a:pPr>
             <a:r>
               <a:rPr lang="en-US" sz="2000" b="0" dirty="0"/>
-              <a:t>Used in TUSREC challenge to evaluate model</a:t>
+              <a:t>Mentioned in </a:t>
+            </a:r>
+            <a:r>
+              <a:rPr lang="en-US" sz="2000" b="0" dirty="0" err="1"/>
+              <a:t>DualTrack</a:t>
+            </a:r>
+            <a:r>
+              <a:rPr lang="en-US" sz="2000" b="0" dirty="0"/>
+              <a:t> paper and TUSREC challenge</a:t>
             </a:r>
           </a:p>
           <a:p>
@@ -6774,6 +6895,159 @@
 </file>
 
 <file path=ppt/slides/slide5.xml><?xml version="1.0" encoding="utf-8"?>
+<p:sld xmlns:a="http://schemas.openxmlformats.org/drawingml/2006/main" xmlns:r="http://schemas.openxmlformats.org/officeDocument/2006/relationships" xmlns:p="http://schemas.openxmlformats.org/presentationml/2006/main">
+  <p:cSld>
+    <p:spTree>
+      <p:nvGrpSpPr>
+        <p:cNvPr id="1" name="">
+          <a:extLst>
+            <a:ext uri="{FF2B5EF4-FFF2-40B4-BE49-F238E27FC236}">
+              <a16:creationId xmlns:a16="http://schemas.microsoft.com/office/drawing/2014/main" id="{D407B051-0EF6-8F7B-56A4-C014AFF651F2}"/>
+            </a:ext>
+          </a:extLst>
+        </p:cNvPr>
+        <p:cNvGrpSpPr/>
+        <p:nvPr/>
+      </p:nvGrpSpPr>
+      <p:grpSpPr>
+        <a:xfrm>
+          <a:off x="0" y="0"/>
+          <a:ext cx="0" cy="0"/>
+          <a:chOff x="0" y="0"/>
+          <a:chExt cx="0" cy="0"/>
+        </a:xfrm>
+      </p:grpSpPr>
+      <p:sp>
+        <p:nvSpPr>
+          <p:cNvPr id="3" name="Slide Number Placeholder 2">
+            <a:extLst>
+              <a:ext uri="{FF2B5EF4-FFF2-40B4-BE49-F238E27FC236}">
+                <a16:creationId xmlns:a16="http://schemas.microsoft.com/office/drawing/2014/main" id="{A78766EF-93D2-0D43-4288-D3C14DFB3187}"/>
+              </a:ext>
+            </a:extLst>
+          </p:cNvPr>
+          <p:cNvSpPr>
+            <a:spLocks noGrp="1"/>
+          </p:cNvSpPr>
+          <p:nvPr>
+            <p:ph type="sldNum" idx="1"/>
+          </p:nvPr>
+        </p:nvSpPr>
+        <p:spPr>
+          <a:xfrm>
+            <a:off x="9093107" y="4704588"/>
+            <a:ext cx="480060" cy="273844"/>
+          </a:xfrm>
+        </p:spPr>
+        <p:txBody>
+          <a:bodyPr/>
+          <a:lstStyle/>
+          <a:p>
+            <a:fld id="{7475F232-FFFE-5E6C-5554-2F165DAD28C0}" type="slidenum">
+              <a:rPr lang="en-JP" smtClean="0"/>
+              <a:t>5</a:t>
+            </a:fld>
+            <a:endParaRPr lang="en-JP" dirty="0"/>
+          </a:p>
+        </p:txBody>
+      </p:sp>
+      <p:sp>
+        <p:nvSpPr>
+          <p:cNvPr id="4" name="Title 3">
+            <a:extLst>
+              <a:ext uri="{FF2B5EF4-FFF2-40B4-BE49-F238E27FC236}">
+                <a16:creationId xmlns:a16="http://schemas.microsoft.com/office/drawing/2014/main" id="{33B2CB50-C8A5-0856-D78D-E98286EBC0A2}"/>
+              </a:ext>
+            </a:extLst>
+          </p:cNvPr>
+          <p:cNvSpPr>
+            <a:spLocks noGrp="1"/>
+          </p:cNvSpPr>
+          <p:nvPr>
+            <p:ph type="title" idx="2"/>
+          </p:nvPr>
+        </p:nvSpPr>
+        <p:spPr/>
+        <p:txBody>
+          <a:bodyPr/>
+          <a:lstStyle/>
+          <a:p>
+            <a:pPr marL="0">
+              <a:buClr>
+                <a:srgbClr val="9E3611"/>
+              </a:buClr>
+            </a:pPr>
+            <a:r>
+              <a:rPr lang="en-US" sz="2400" dirty="0">
+                <a:ea typeface="游ゴシック Medium"/>
+                <a:cs typeface="Times New Roman"/>
+              </a:rPr>
+              <a:t>   Pose Graph Optimization</a:t>
+            </a:r>
+          </a:p>
+        </p:txBody>
+      </p:sp>
+      <p:sp>
+        <p:nvSpPr>
+          <p:cNvPr id="16" name="Text Placeholder 1">
+            <a:extLst>
+              <a:ext uri="{FF2B5EF4-FFF2-40B4-BE49-F238E27FC236}">
+                <a16:creationId xmlns:a16="http://schemas.microsoft.com/office/drawing/2014/main" id="{00107EA1-420E-69FE-51CB-AEE3F5273065}"/>
+              </a:ext>
+            </a:extLst>
+          </p:cNvPr>
+          <p:cNvSpPr>
+            <a:spLocks noGrp="1"/>
+          </p:cNvSpPr>
+          <p:nvPr>
+            <p:ph type="body"/>
+          </p:nvPr>
+        </p:nvSpPr>
+        <p:spPr>
+          <a:xfrm>
+            <a:off x="170325" y="707816"/>
+            <a:ext cx="8218099" cy="3986866"/>
+          </a:xfrm>
+        </p:spPr>
+        <p:txBody>
+          <a:bodyPr vert="horz" lIns="91440" tIns="45720" rIns="91440" bIns="45720" rtlCol="0" anchor="t">
+            <a:normAutofit/>
+          </a:bodyPr>
+          <a:lstStyle/>
+          <a:p>
+            <a:pPr marL="0" indent="0">
+              <a:buClr>
+                <a:srgbClr val="9E3611"/>
+              </a:buClr>
+              <a:buNone/>
+            </a:pPr>
+            <a:endParaRPr lang="en-US" sz="2000" b="0" dirty="0"/>
+          </a:p>
+          <a:p>
+            <a:pPr marL="0" indent="0">
+              <a:buClr>
+                <a:srgbClr val="9E3611"/>
+              </a:buClr>
+              <a:buNone/>
+            </a:pPr>
+            <a:endParaRPr lang="en-US" sz="2000" b="0" dirty="0"/>
+          </a:p>
+        </p:txBody>
+      </p:sp>
+    </p:spTree>
+    <p:extLst>
+      <p:ext uri="{BB962C8B-B14F-4D97-AF65-F5344CB8AC3E}">
+        <p14:creationId xmlns:p14="http://schemas.microsoft.com/office/powerpoint/2010/main" val="1411381841"/>
+      </p:ext>
+    </p:extLst>
+  </p:cSld>
+  <p:clrMapOvr>
+    <a:masterClrMapping/>
+  </p:clrMapOvr>
+</p:sld>
+</file>
+
+<file path=ppt/slides/slide6.xml><?xml version="1.0" encoding="utf-8"?>
 <p:sld xmlns:a="http://schemas.openxmlformats.org/drawingml/2006/main" xmlns:r="http://schemas.openxmlformats.org/officeDocument/2006/relationships" xmlns:p="http://schemas.openxmlformats.org/presentationml/2006/main">
   <p:cSld>
     <p:spTree>
@@ -6824,7 +7098,7 @@
           <a:p>
             <a:fld id="{7475F232-FFFE-5E6C-5554-2F165DAD28C0}" type="slidenum">
               <a:rPr lang="en-JP" smtClean="0"/>
-              <a:t>5</a:t>
+              <a:t>6</a:t>
             </a:fld>
             <a:endParaRPr lang="en-JP" dirty="0"/>
           </a:p>
@@ -6881,7 +7155,7 @@
           <p:nvPr>
             <p:extLst>
               <p:ext uri="{D42A27DB-BD31-4B8C-83A1-F6EECF244321}">
-                <p14:modId xmlns:p14="http://schemas.microsoft.com/office/powerpoint/2010/main" val="1626087587"/>
+                <p14:modId xmlns:p14="http://schemas.microsoft.com/office/powerpoint/2010/main" val="4214190468"/>
               </p:ext>
             </p:extLst>
           </p:nvPr>
@@ -7221,21 +7495,8 @@
                             <a:schemeClr val="bg1"/>
                           </a:solidFill>
                         </a:rPr>
-                        <a:t>(</a:t>
+                        <a:t>(six scans)</a:t>
                       </a:r>
-                      <a:r>
-                        <a:rPr lang="en-US" b="1">
-                          <a:solidFill>
-                            <a:schemeClr val="bg1"/>
-                          </a:solidFill>
-                        </a:rPr>
-                        <a:t>six scans)</a:t>
-                      </a:r>
-                      <a:endParaRPr lang="en-US" b="1" dirty="0">
-                        <a:solidFill>
-                          <a:schemeClr val="bg1"/>
-                        </a:solidFill>
-                      </a:endParaRPr>
                     </a:p>
                   </a:txBody>
                   <a:tcPr>
@@ -7341,8 +7602,13 @@
                     <a:p>
                       <a:r>
                         <a:rPr lang="en-US" dirty="0"/>
-                        <a:t>/</a:t>
+                        <a:t>FDR</a:t>
                       </a:r>
+                      <a:r>
+                        <a:rPr lang="en-US"/>
+                        <a:t>: 72.47%</a:t>
+                      </a:r>
+                      <a:endParaRPr lang="en-US" dirty="0"/>
                     </a:p>
                   </a:txBody>
                   <a:tcPr/>
@@ -7408,7 +7674,7 @@
 </p:sld>
 </file>
 
-<file path=ppt/slides/slide6.xml><?xml version="1.0" encoding="utf-8"?>
+<file path=ppt/slides/slide7.xml><?xml version="1.0" encoding="utf-8"?>
 <p:sld xmlns:a="http://schemas.openxmlformats.org/drawingml/2006/main" xmlns:r="http://schemas.openxmlformats.org/officeDocument/2006/relationships" xmlns:p="http://schemas.openxmlformats.org/presentationml/2006/main">
   <p:cSld>
     <p:spTree>
@@ -7459,7 +7725,7 @@
           <a:p>
             <a:fld id="{7475F232-FFFE-5E6C-5554-2F165DAD28C0}" type="slidenum">
               <a:rPr lang="en-JP" smtClean="0"/>
-              <a:t>6</a:t>
+              <a:t>7</a:t>
             </a:fld>
             <a:endParaRPr lang="en-JP" dirty="0"/>
           </a:p>
@@ -7591,7 +7857,7 @@
             </a:pPr>
             <a:r>
               <a:rPr lang="en-US" sz="2000" dirty="0"/>
-              <a:t>No cross-evaluation:</a:t>
+              <a:t>Low performance for cross-evaluation:</a:t>
             </a:r>
           </a:p>
           <a:p>
@@ -7602,15 +7868,25 @@
             </a:pPr>
             <a:r>
               <a:rPr lang="en-US" sz="2000" b="0" dirty="0"/>
-              <a:t>Different data structure TUSREC24 and TUSREC25 data sets (frame number, )</a:t>
-            </a:r>
-          </a:p>
-          <a:p>
-            <a:pPr marL="0" indent="0">
+              <a:t>Different TUSREC24 and TUSREC25 data sets</a:t>
+            </a:r>
+          </a:p>
+          <a:p>
+            <a:pPr>
               <a:buClr>
                 <a:srgbClr val="9E3611"/>
               </a:buClr>
-              <a:buNone/>
+            </a:pPr>
+            <a:r>
+              <a:rPr lang="en-US" sz="2000" b="0" dirty="0"/>
+              <a:t>No calibration or retraining of models</a:t>
+            </a:r>
+          </a:p>
+          <a:p>
+            <a:pPr>
+              <a:buClr>
+                <a:srgbClr val="9E3611"/>
+              </a:buClr>
             </a:pPr>
             <a:endParaRPr lang="en-US" sz="2000" b="0" dirty="0"/>
           </a:p>

</xml_diff>

<commit_message>
apply base pgo to DT25 on 24 data
</commit_message>
<xml_diff>
--- a/documents/presentations/Jannis_Meyer_Presentation_01_06_2026.pptx
+++ b/documents/presentations/Jannis_Meyer_Presentation_01_06_2026.pptx
@@ -5,7 +5,7 @@
     <p:sldMasterId id="2284242785" r:id="rId4"/>
   </p:sldMasterIdLst>
   <p:notesMasterIdLst>
-    <p:notesMasterId r:id="rId12"/>
+    <p:notesMasterId r:id="rId13"/>
   </p:notesMasterIdLst>
   <p:sldIdLst>
     <p:sldId id="256" r:id="rId5"/>
@@ -15,6 +15,7 @@
     <p:sldId id="286" r:id="rId9"/>
     <p:sldId id="283" r:id="rId10"/>
     <p:sldId id="285" r:id="rId11"/>
+    <p:sldId id="287" r:id="rId12"/>
   </p:sldIdLst>
   <p:sldSz cx="9144000" cy="5143500" type="screen16x9"/>
   <p:notesSz cx="9144000" cy="6858000"/>
@@ -816,6 +817,107 @@
     <p:extLst>
       <p:ext uri="{BB962C8B-B14F-4D97-AF65-F5344CB8AC3E}">
         <p14:creationId xmlns:p14="http://schemas.microsoft.com/office/powerpoint/2010/main" val="3196550776"/>
+      </p:ext>
+    </p:extLst>
+  </p:cSld>
+  <p:clrMapOvr>
+    <a:masterClrMapping/>
+  </p:clrMapOvr>
+</p:notes>
+</file>
+
+<file path=ppt/notesSlides/notesSlide7.xml><?xml version="1.0" encoding="utf-8"?>
+<p:notes xmlns:a="http://schemas.openxmlformats.org/drawingml/2006/main" xmlns:r="http://schemas.openxmlformats.org/officeDocument/2006/relationships" xmlns:p="http://schemas.openxmlformats.org/presentationml/2006/main">
+  <p:cSld>
+    <p:spTree>
+      <p:nvGrpSpPr>
+        <p:cNvPr id="1" name="">
+          <a:extLst>
+            <a:ext uri="{FF2B5EF4-FFF2-40B4-BE49-F238E27FC236}">
+              <a16:creationId xmlns:a16="http://schemas.microsoft.com/office/drawing/2014/main" id="{FAFC1803-8A6C-3FBD-DBC2-FA922A28530A}"/>
+            </a:ext>
+          </a:extLst>
+        </p:cNvPr>
+        <p:cNvGrpSpPr/>
+        <p:nvPr/>
+      </p:nvGrpSpPr>
+      <p:grpSpPr>
+        <a:xfrm>
+          <a:off x="0" y="0"/>
+          <a:ext cx="0" cy="0"/>
+          <a:chOff x="0" y="0"/>
+          <a:chExt cx="0" cy="0"/>
+        </a:xfrm>
+      </p:grpSpPr>
+      <p:sp>
+        <p:nvSpPr>
+          <p:cNvPr id="2" name="Slide Image Placeholder 1">
+            <a:extLst>
+              <a:ext uri="{FF2B5EF4-FFF2-40B4-BE49-F238E27FC236}">
+                <a16:creationId xmlns:a16="http://schemas.microsoft.com/office/drawing/2014/main" id="{55E8D1BF-7DF1-BD75-8C21-EB8F2C8576A4}"/>
+              </a:ext>
+            </a:extLst>
+          </p:cNvPr>
+          <p:cNvSpPr>
+            <a:spLocks noGrp="1" noRot="1" noChangeAspect="1"/>
+          </p:cNvSpPr>
+          <p:nvPr>
+            <p:ph type="sldImg"/>
+          </p:nvPr>
+        </p:nvSpPr>
+        <p:spPr>
+          <a:xfrm>
+            <a:off x="2514600" y="857250"/>
+            <a:ext cx="4114800" cy="2314575"/>
+          </a:xfrm>
+          <a:prstGeom prst="rect">
+            <a:avLst/>
+          </a:prstGeom>
+          <a:noFill/>
+          <a:ln w="12700">
+            <a:solidFill>
+              <a:prstClr val="black"/>
+            </a:solidFill>
+          </a:ln>
+        </p:spPr>
+      </p:sp>
+      <p:sp>
+        <p:nvSpPr>
+          <p:cNvPr id="3" name="Notes Placeholder 2">
+            <a:extLst>
+              <a:ext uri="{FF2B5EF4-FFF2-40B4-BE49-F238E27FC236}">
+                <a16:creationId xmlns:a16="http://schemas.microsoft.com/office/drawing/2014/main" id="{188AB29E-5148-BED2-2406-67334CE64D93}"/>
+              </a:ext>
+            </a:extLst>
+          </p:cNvPr>
+          <p:cNvSpPr>
+            <a:spLocks noGrp="1"/>
+          </p:cNvSpPr>
+          <p:nvPr>
+            <p:ph type="body" idx="1"/>
+          </p:nvPr>
+        </p:nvSpPr>
+        <p:spPr>
+          <a:xfrm>
+            <a:off x="914400" y="3300413"/>
+            <a:ext cx="7315200" cy="2700337"/>
+          </a:xfrm>
+          <a:prstGeom prst="rect">
+            <a:avLst/>
+          </a:prstGeom>
+        </p:spPr>
+        <p:txBody>
+          <a:bodyPr/>
+          <a:lstStyle/>
+          <a:p>
+            <a:endParaRPr lang="en-US" dirty="0"/>
+          </a:p>
+        </p:txBody>
+      </p:sp>
+    </p:spTree>
+    <p:extLst>
+      <p:ext uri="{BB962C8B-B14F-4D97-AF65-F5344CB8AC3E}">
+        <p14:creationId xmlns:p14="http://schemas.microsoft.com/office/powerpoint/2010/main" val="3715969738"/>
       </p:ext>
     </p:extLst>
   </p:cSld>
@@ -6676,7 +6778,7 @@
         </p:spPr>
         <p:txBody>
           <a:bodyPr vert="horz" lIns="91440" tIns="45720" rIns="91440" bIns="45720" rtlCol="0" anchor="t">
-            <a:normAutofit fontScale="92500" lnSpcReduction="10000"/>
+            <a:noAutofit/>
           </a:bodyPr>
           <a:lstStyle/>
           <a:p>
@@ -6731,15 +6833,6 @@
               </a:buClr>
               <a:buNone/>
             </a:pPr>
-            <a:endParaRPr lang="en-US" sz="2000" b="0" dirty="0"/>
-          </a:p>
-          <a:p>
-            <a:pPr marL="0" indent="0">
-              <a:buClr>
-                <a:srgbClr val="9E3611"/>
-              </a:buClr>
-              <a:buNone/>
-            </a:pPr>
             <a:r>
               <a:rPr lang="en-US" sz="2000" dirty="0"/>
               <a:t>Global Point Error (GPE):</a:t>
@@ -6752,7 +6845,7 @@
               </a:buClr>
             </a:pPr>
             <a:r>
-              <a:rPr lang="en-US" sz="2000" b="0" dirty="0"/>
+              <a:rPr lang="en-US" sz="2000" b="0" i="1" dirty="0"/>
               <a:t>“Average point error between the true position and the fully reconstructed trajectory estimate at each timestep”</a:t>
             </a:r>
           </a:p>
@@ -7034,6 +7127,403 @@
           </a:p>
         </p:txBody>
       </p:sp>
+      <p:sp>
+        <p:nvSpPr>
+          <p:cNvPr id="5" name="Text Placeholder 1">
+            <a:extLst>
+              <a:ext uri="{FF2B5EF4-FFF2-40B4-BE49-F238E27FC236}">
+                <a16:creationId xmlns:a16="http://schemas.microsoft.com/office/drawing/2014/main" id="{8E78D97E-74FD-2C66-7EBF-94EB233ED3EB}"/>
+              </a:ext>
+            </a:extLst>
+          </p:cNvPr>
+          <p:cNvSpPr txBox="1">
+            <a:spLocks/>
+          </p:cNvSpPr>
+          <p:nvPr/>
+        </p:nvSpPr>
+        <p:spPr>
+          <a:xfrm>
+            <a:off x="322725" y="860216"/>
+            <a:ext cx="8218099" cy="3986866"/>
+          </a:xfrm>
+          <a:prstGeom prst="rect">
+            <a:avLst/>
+          </a:prstGeom>
+          <a:noFill/>
+        </p:spPr>
+        <p:txBody>
+          <a:bodyPr vert="horz" lIns="91440" tIns="45720" rIns="91440" bIns="45720" rtlCol="0" anchor="t">
+            <a:normAutofit/>
+          </a:bodyPr>
+          <a:lstStyle>
+            <a:lvl1pPr marL="137160" indent="-137160" algn="l" defTabSz="685800" rtl="0" eaLnBrk="1" latinLnBrk="0" hangingPunct="1">
+              <a:lnSpc>
+                <a:spcPct val="90000"/>
+              </a:lnSpc>
+              <a:spcBef>
+                <a:spcPts val="900"/>
+              </a:spcBef>
+              <a:buClr>
+                <a:schemeClr val="accent1">
+                  <a:lumMod val="75000"/>
+                </a:schemeClr>
+              </a:buClr>
+              <a:buSzPct val="100000"/>
+              <a:buFont typeface="Arial" panose="020B0604020202020204" pitchFamily="34" charset="0"/>
+              <a:buChar char="•"/>
+              <a:defRPr kumimoji="1" sz="1500" b="1" kern="1200">
+                <a:solidFill>
+                  <a:schemeClr val="tx1"/>
+                </a:solidFill>
+                <a:latin typeface="游ゴシック Medium" panose="020B0500000000000000" pitchFamily="50" charset="-128"/>
+                <a:ea typeface="游ゴシック Medium" panose="020B0500000000000000" pitchFamily="50" charset="-128"/>
+                <a:cs typeface="+mn-cs"/>
+              </a:defRPr>
+            </a:lvl1pPr>
+            <a:lvl2pPr marL="342900" indent="-137160" algn="l" defTabSz="685800" rtl="0" eaLnBrk="1" latinLnBrk="0" hangingPunct="1">
+              <a:lnSpc>
+                <a:spcPct val="90000"/>
+              </a:lnSpc>
+              <a:spcBef>
+                <a:spcPts val="300"/>
+              </a:spcBef>
+              <a:spcAft>
+                <a:spcPts val="150"/>
+              </a:spcAft>
+              <a:buClr>
+                <a:schemeClr val="accent1">
+                  <a:lumMod val="75000"/>
+                </a:schemeClr>
+              </a:buClr>
+              <a:buSzPct val="100000"/>
+              <a:buFont typeface="Arial" panose="020B0604020202020204" pitchFamily="34" charset="0"/>
+              <a:buChar char="•"/>
+              <a:defRPr kumimoji="1" sz="1350" b="1" kern="1200">
+                <a:solidFill>
+                  <a:schemeClr val="tx1"/>
+                </a:solidFill>
+                <a:latin typeface="游ゴシック Medium" panose="020B0500000000000000" pitchFamily="50" charset="-128"/>
+                <a:ea typeface="游ゴシック Medium" panose="020B0500000000000000" pitchFamily="50" charset="-128"/>
+                <a:cs typeface="+mn-cs"/>
+              </a:defRPr>
+            </a:lvl2pPr>
+            <a:lvl3pPr marL="548640" indent="-137160" algn="l" defTabSz="685800" rtl="0" eaLnBrk="1" latinLnBrk="0" hangingPunct="1">
+              <a:lnSpc>
+                <a:spcPct val="90000"/>
+              </a:lnSpc>
+              <a:spcBef>
+                <a:spcPts val="300"/>
+              </a:spcBef>
+              <a:spcAft>
+                <a:spcPts val="150"/>
+              </a:spcAft>
+              <a:buClr>
+                <a:schemeClr val="accent1">
+                  <a:lumMod val="75000"/>
+                </a:schemeClr>
+              </a:buClr>
+              <a:buSzPct val="100000"/>
+              <a:buFont typeface="Arial" panose="020B0604020202020204" pitchFamily="34" charset="0"/>
+              <a:buChar char="•"/>
+              <a:defRPr kumimoji="1" sz="1200" b="1" kern="1200">
+                <a:solidFill>
+                  <a:schemeClr val="tx1"/>
+                </a:solidFill>
+                <a:latin typeface="游ゴシック Medium" panose="020B0500000000000000" pitchFamily="50" charset="-128"/>
+                <a:ea typeface="游ゴシック Medium" panose="020B0500000000000000" pitchFamily="50" charset="-128"/>
+                <a:cs typeface="+mn-cs"/>
+              </a:defRPr>
+            </a:lvl3pPr>
+            <a:lvl4pPr marL="754380" indent="-137160" algn="l" defTabSz="685800" rtl="0" eaLnBrk="1" latinLnBrk="0" hangingPunct="1">
+              <a:lnSpc>
+                <a:spcPct val="90000"/>
+              </a:lnSpc>
+              <a:spcBef>
+                <a:spcPts val="300"/>
+              </a:spcBef>
+              <a:spcAft>
+                <a:spcPts val="150"/>
+              </a:spcAft>
+              <a:buClr>
+                <a:schemeClr val="accent1">
+                  <a:lumMod val="75000"/>
+                </a:schemeClr>
+              </a:buClr>
+              <a:buSzPct val="100000"/>
+              <a:buFont typeface="Arial" panose="020B0604020202020204" pitchFamily="34" charset="0"/>
+              <a:buChar char="•"/>
+              <a:defRPr kumimoji="1" sz="1200" b="1" kern="1200">
+                <a:solidFill>
+                  <a:schemeClr val="tx1"/>
+                </a:solidFill>
+                <a:latin typeface="游ゴシック Medium" panose="020B0500000000000000" pitchFamily="50" charset="-128"/>
+                <a:ea typeface="游ゴシック Medium" panose="020B0500000000000000" pitchFamily="50" charset="-128"/>
+                <a:cs typeface="+mn-cs"/>
+              </a:defRPr>
+            </a:lvl4pPr>
+            <a:lvl5pPr marL="960120" indent="-137160" algn="l" defTabSz="685800" rtl="0" eaLnBrk="1" latinLnBrk="0" hangingPunct="1">
+              <a:lnSpc>
+                <a:spcPct val="90000"/>
+              </a:lnSpc>
+              <a:spcBef>
+                <a:spcPts val="300"/>
+              </a:spcBef>
+              <a:spcAft>
+                <a:spcPts val="150"/>
+              </a:spcAft>
+              <a:buClr>
+                <a:schemeClr val="accent1">
+                  <a:lumMod val="75000"/>
+                </a:schemeClr>
+              </a:buClr>
+              <a:buSzPct val="100000"/>
+              <a:buFont typeface="Arial" panose="020B0604020202020204" pitchFamily="34" charset="0"/>
+              <a:buChar char="•"/>
+              <a:defRPr kumimoji="1" sz="1200" b="1" kern="1200">
+                <a:solidFill>
+                  <a:schemeClr val="tx1"/>
+                </a:solidFill>
+                <a:latin typeface="游ゴシック Medium" panose="020B0500000000000000" pitchFamily="50" charset="-128"/>
+                <a:ea typeface="游ゴシック Medium" panose="020B0500000000000000" pitchFamily="50" charset="-128"/>
+                <a:cs typeface="+mn-cs"/>
+              </a:defRPr>
+            </a:lvl5pPr>
+            <a:lvl6pPr marL="1200000" indent="-171450" algn="l" defTabSz="685800" rtl="0" eaLnBrk="1" latinLnBrk="0" hangingPunct="1">
+              <a:lnSpc>
+                <a:spcPct val="90000"/>
+              </a:lnSpc>
+              <a:spcBef>
+                <a:spcPts val="300"/>
+              </a:spcBef>
+              <a:spcAft>
+                <a:spcPts val="150"/>
+              </a:spcAft>
+              <a:buClr>
+                <a:schemeClr val="accent1">
+                  <a:lumMod val="75000"/>
+                </a:schemeClr>
+              </a:buClr>
+              <a:buSzPct val="100000"/>
+              <a:buFont typeface="Arial" panose="020B0604020202020204" pitchFamily="34" charset="0"/>
+              <a:buChar char="•"/>
+              <a:defRPr kumimoji="1" sz="1200" kern="1200">
+                <a:solidFill>
+                  <a:schemeClr val="tx1"/>
+                </a:solidFill>
+                <a:latin typeface="+mn-lt"/>
+                <a:ea typeface="+mn-ea"/>
+                <a:cs typeface="+mn-cs"/>
+              </a:defRPr>
+            </a:lvl6pPr>
+            <a:lvl7pPr marL="1425000" indent="-171450" algn="l" defTabSz="685800" rtl="0" eaLnBrk="1" latinLnBrk="0" hangingPunct="1">
+              <a:lnSpc>
+                <a:spcPct val="90000"/>
+              </a:lnSpc>
+              <a:spcBef>
+                <a:spcPts val="300"/>
+              </a:spcBef>
+              <a:spcAft>
+                <a:spcPts val="150"/>
+              </a:spcAft>
+              <a:buClr>
+                <a:schemeClr val="accent1">
+                  <a:lumMod val="75000"/>
+                </a:schemeClr>
+              </a:buClr>
+              <a:buSzPct val="100000"/>
+              <a:buFont typeface="Arial" panose="020B0604020202020204" pitchFamily="34" charset="0"/>
+              <a:buChar char="•"/>
+              <a:defRPr kumimoji="1" sz="1200" kern="1200">
+                <a:solidFill>
+                  <a:schemeClr val="tx1"/>
+                </a:solidFill>
+                <a:latin typeface="+mn-lt"/>
+                <a:ea typeface="+mn-ea"/>
+                <a:cs typeface="+mn-cs"/>
+              </a:defRPr>
+            </a:lvl7pPr>
+            <a:lvl8pPr marL="1650000" indent="-171450" algn="l" defTabSz="685800" rtl="0" eaLnBrk="1" latinLnBrk="0" hangingPunct="1">
+              <a:lnSpc>
+                <a:spcPct val="90000"/>
+              </a:lnSpc>
+              <a:spcBef>
+                <a:spcPts val="300"/>
+              </a:spcBef>
+              <a:spcAft>
+                <a:spcPts val="150"/>
+              </a:spcAft>
+              <a:buClr>
+                <a:schemeClr val="accent1">
+                  <a:lumMod val="75000"/>
+                </a:schemeClr>
+              </a:buClr>
+              <a:buSzPct val="100000"/>
+              <a:buFont typeface="Arial" panose="020B0604020202020204" pitchFamily="34" charset="0"/>
+              <a:buChar char="•"/>
+              <a:defRPr kumimoji="1" sz="1200" kern="1200">
+                <a:solidFill>
+                  <a:schemeClr val="tx1"/>
+                </a:solidFill>
+                <a:latin typeface="+mn-lt"/>
+                <a:ea typeface="+mn-ea"/>
+                <a:cs typeface="+mn-cs"/>
+              </a:defRPr>
+            </a:lvl8pPr>
+            <a:lvl9pPr marL="1875000" indent="-171450" algn="l" defTabSz="685800" rtl="0" eaLnBrk="1" latinLnBrk="0" hangingPunct="1">
+              <a:lnSpc>
+                <a:spcPct val="90000"/>
+              </a:lnSpc>
+              <a:spcBef>
+                <a:spcPts val="300"/>
+              </a:spcBef>
+              <a:spcAft>
+                <a:spcPts val="150"/>
+              </a:spcAft>
+              <a:buClr>
+                <a:schemeClr val="accent1">
+                  <a:lumMod val="75000"/>
+                </a:schemeClr>
+              </a:buClr>
+              <a:buSzPct val="100000"/>
+              <a:buFont typeface="Arial" panose="020B0604020202020204" pitchFamily="34" charset="0"/>
+              <a:buChar char="•"/>
+              <a:defRPr kumimoji="1" sz="1200" kern="1200">
+                <a:solidFill>
+                  <a:schemeClr val="tx1"/>
+                </a:solidFill>
+                <a:latin typeface="+mn-lt"/>
+                <a:ea typeface="+mn-ea"/>
+                <a:cs typeface="+mn-cs"/>
+              </a:defRPr>
+            </a:lvl9pPr>
+          </a:lstStyle>
+          <a:p>
+            <a:pPr marL="0" indent="0">
+              <a:buClr>
+                <a:srgbClr val="9E3611"/>
+              </a:buClr>
+              <a:buFont typeface="Arial" panose="020B0604020202020204" pitchFamily="34" charset="0"/>
+              <a:buNone/>
+            </a:pPr>
+            <a:r>
+              <a:rPr lang="en-US" sz="2000" dirty="0"/>
+              <a:t>Optimizer:</a:t>
+            </a:r>
+          </a:p>
+          <a:p>
+            <a:pPr>
+              <a:buClr>
+                <a:srgbClr val="9E3611"/>
+              </a:buClr>
+            </a:pPr>
+            <a:r>
+              <a:rPr lang="en-US" sz="2000" b="0" dirty="0"/>
+              <a:t>Levenberg-Marquardt: Additional factor to Jacobi-matrices for solving linear optimization problem</a:t>
+            </a:r>
+          </a:p>
+          <a:p>
+            <a:pPr marL="0" indent="0">
+              <a:buClr>
+                <a:srgbClr val="9E3611"/>
+              </a:buClr>
+              <a:buNone/>
+            </a:pPr>
+            <a:endParaRPr lang="en-US" sz="2000" b="0" dirty="0"/>
+          </a:p>
+          <a:p>
+            <a:pPr marL="0" indent="0">
+              <a:buClr>
+                <a:srgbClr val="9E3611"/>
+              </a:buClr>
+              <a:buNone/>
+            </a:pPr>
+            <a:r>
+              <a:rPr lang="en-US" sz="2000" dirty="0"/>
+              <a:t>Weights:</a:t>
+            </a:r>
+          </a:p>
+          <a:p>
+            <a:pPr>
+              <a:buClr>
+                <a:srgbClr val="9E3611"/>
+              </a:buClr>
+            </a:pPr>
+            <a:r>
+              <a:rPr lang="en-US" sz="2000" b="0" dirty="0"/>
+              <a:t>Prior (first node): 6*10</a:t>
+            </a:r>
+            <a:r>
+              <a:rPr lang="en-US" sz="2000" b="0" baseline="30000" dirty="0"/>
+              <a:t>5</a:t>
+            </a:r>
+            <a:endParaRPr lang="en-US" sz="2000" b="0" dirty="0"/>
+          </a:p>
+          <a:p>
+            <a:pPr>
+              <a:buClr>
+                <a:srgbClr val="9E3611"/>
+              </a:buClr>
+            </a:pPr>
+            <a:r>
+              <a:rPr lang="en-US" sz="2000" b="0" dirty="0"/>
+              <a:t>Rest: 6*10</a:t>
+            </a:r>
+            <a:r>
+              <a:rPr lang="en-US" sz="2000" b="0" baseline="30000" dirty="0"/>
+              <a:t>2</a:t>
+            </a:r>
+          </a:p>
+          <a:p>
+            <a:pPr marL="0" indent="0">
+              <a:buClr>
+                <a:srgbClr val="9E3611"/>
+              </a:buClr>
+              <a:buNone/>
+            </a:pPr>
+            <a:endParaRPr lang="en-US" sz="2000" b="0" baseline="30000" dirty="0"/>
+          </a:p>
+          <a:p>
+            <a:pPr marL="0" indent="0">
+              <a:buClr>
+                <a:srgbClr val="9E3611"/>
+              </a:buClr>
+              <a:buNone/>
+            </a:pPr>
+            <a:r>
+              <a:rPr lang="en-US" sz="2000" dirty="0">
+                <a:solidFill>
+                  <a:schemeClr val="accent1"/>
+                </a:solidFill>
+              </a:rPr>
+              <a:t>➔ </a:t>
+            </a:r>
+            <a:r>
+              <a:rPr lang="en-US" sz="2000" b="0" dirty="0"/>
+              <a:t>Base line PGO, no individual weighting nor additional edges yet</a:t>
+            </a:r>
+          </a:p>
+          <a:p>
+            <a:pPr marL="0" indent="0">
+              <a:buClr>
+                <a:srgbClr val="9E3611"/>
+              </a:buClr>
+              <a:buFont typeface="Arial" panose="020B0604020202020204" pitchFamily="34" charset="0"/>
+              <a:buNone/>
+            </a:pPr>
+            <a:endParaRPr lang="en-US" sz="2000" b="0" dirty="0"/>
+          </a:p>
+          <a:p>
+            <a:pPr marL="0" indent="0">
+              <a:buClr>
+                <a:srgbClr val="9E3611"/>
+              </a:buClr>
+              <a:buFont typeface="Arial" panose="020B0604020202020204" pitchFamily="34" charset="0"/>
+              <a:buNone/>
+            </a:pPr>
+            <a:endParaRPr lang="en-US" sz="2000" b="0" dirty="0"/>
+          </a:p>
+        </p:txBody>
+      </p:sp>
     </p:spTree>
     <p:extLst>
       <p:ext uri="{BB962C8B-B14F-4D97-AF65-F5344CB8AC3E}">
@@ -7155,7 +7645,7 @@
           <p:nvPr>
             <p:extLst>
               <p:ext uri="{D42A27DB-BD31-4B8C-83A1-F6EECF244321}">
-                <p14:modId xmlns:p14="http://schemas.microsoft.com/office/powerpoint/2010/main" val="4214190468"/>
+                <p14:modId xmlns:p14="http://schemas.microsoft.com/office/powerpoint/2010/main" val="759695160"/>
               </p:ext>
             </p:extLst>
           </p:nvPr>
@@ -7380,7 +7870,7 @@
                           <a:ea typeface="+mn-ea"/>
                           <a:cs typeface="+mn-cs"/>
                         </a:rPr>
-                        <a:t>28.54%</a:t>
+                        <a:t>28.5%</a:t>
                       </a:r>
                     </a:p>
                     <a:p>
@@ -7427,7 +7917,7 @@
                     <a:p>
                       <a:r>
                         <a:rPr lang="en-US" dirty="0"/>
-                        <a:t>/</a:t>
+                        <a:t>FDR: 28.6%</a:t>
                       </a:r>
                     </a:p>
                   </a:txBody>
@@ -7520,7 +8010,7 @@
                           <a:ea typeface="+mn-ea"/>
                           <a:cs typeface="+mn-cs"/>
                         </a:rPr>
-                        <a:t>FDR: 488.77%</a:t>
+                        <a:t>FDR: 488.8%</a:t>
                       </a:r>
                     </a:p>
                     <a:p>
@@ -7545,7 +8035,7 @@
                           <a:ea typeface="+mn-ea"/>
                           <a:cs typeface="+mn-cs"/>
                         </a:rPr>
-                        <a:t>GPE: 56.53mm</a:t>
+                        <a:t>GPE: 56.5mm</a:t>
                       </a:r>
                     </a:p>
                   </a:txBody>
@@ -7602,13 +8092,8 @@
                     <a:p>
                       <a:r>
                         <a:rPr lang="en-US" dirty="0"/>
-                        <a:t>FDR</a:t>
+                        <a:t>FDR: 72.5%</a:t>
                       </a:r>
-                      <a:r>
-                        <a:rPr lang="en-US"/>
-                        <a:t>: 72.47%</a:t>
-                      </a:r>
-                      <a:endParaRPr lang="en-US" dirty="0"/>
                     </a:p>
                   </a:txBody>
                   <a:tcPr/>
@@ -7758,12 +8243,16 @@
               </a:buClr>
             </a:pPr>
             <a:r>
-              <a:rPr lang="en-US" sz="2400" dirty="0">
+              <a:rPr lang="en-US" sz="2400">
                 <a:ea typeface="游ゴシック Medium"/>
                 <a:cs typeface="Times New Roman"/>
               </a:rPr>
-              <a:t>   Explanations</a:t>
-            </a:r>
+              <a:t>   Explanations of Results</a:t>
+            </a:r>
+            <a:endParaRPr lang="en-US" sz="2400" dirty="0">
+              <a:ea typeface="游ゴシック Medium"/>
+              <a:cs typeface="Times New Roman"/>
+            </a:endParaRPr>
           </a:p>
         </p:txBody>
       </p:sp>
@@ -7791,7 +8280,7 @@
         </p:spPr>
         <p:txBody>
           <a:bodyPr vert="horz" lIns="91440" tIns="45720" rIns="91440" bIns="45720" rtlCol="0" anchor="t">
-            <a:normAutofit/>
+            <a:normAutofit lnSpcReduction="10000"/>
           </a:bodyPr>
           <a:lstStyle/>
           <a:p>
@@ -7837,6 +8326,48 @@
             <a:r>
               <a:rPr lang="en-US" sz="2000" b="0" dirty="0"/>
               <a:t>TUSREC challenge rating does not evaluate FDR</a:t>
+            </a:r>
+          </a:p>
+          <a:p>
+            <a:pPr>
+              <a:buClr>
+                <a:srgbClr val="9E3611"/>
+              </a:buClr>
+            </a:pPr>
+            <a:endParaRPr lang="en-US" sz="2000" b="0" dirty="0"/>
+          </a:p>
+          <a:p>
+            <a:pPr marL="0" indent="0">
+              <a:buClr>
+                <a:srgbClr val="9E3611"/>
+              </a:buClr>
+              <a:buNone/>
+            </a:pPr>
+            <a:r>
+              <a:rPr lang="en-US" sz="2000" dirty="0"/>
+              <a:t>Low performance for cross-evaluation:</a:t>
+            </a:r>
+          </a:p>
+          <a:p>
+            <a:pPr>
+              <a:buClr>
+                <a:srgbClr val="9E3611"/>
+              </a:buClr>
+            </a:pPr>
+            <a:r>
+              <a:rPr lang="en-US" sz="2000" b="0" dirty="0"/>
+              <a:t>Different TUSREC24 and TUSREC25 data sets</a:t>
+            </a:r>
+          </a:p>
+          <a:p>
+            <a:pPr>
+              <a:buClr>
+                <a:srgbClr val="9E3611"/>
+              </a:buClr>
+            </a:pPr>
+            <a:r>
+              <a:rPr lang="en-US" sz="2000" b="0" dirty="0"/>
+              <a:t>No calibration or retraining of models</a:t>
             </a:r>
           </a:p>
           <a:p>
@@ -7857,7 +8388,7 @@
             </a:pPr>
             <a:r>
               <a:rPr lang="en-US" sz="2000" dirty="0"/>
-              <a:t>Low performance for cross-evaluation:</a:t>
+              <a:t>Near-zero improvement from PGO:</a:t>
             </a:r>
           </a:p>
           <a:p>
@@ -7868,27 +8399,8 @@
             </a:pPr>
             <a:r>
               <a:rPr lang="en-US" sz="2000" b="0" dirty="0"/>
-              <a:t>Different TUSREC24 and TUSREC25 data sets</a:t>
-            </a:r>
-          </a:p>
-          <a:p>
-            <a:pPr>
-              <a:buClr>
-                <a:srgbClr val="9E3611"/>
-              </a:buClr>
-            </a:pPr>
-            <a:r>
-              <a:rPr lang="en-US" sz="2000" b="0" dirty="0"/>
-              <a:t>No calibration or retraining of models</a:t>
-            </a:r>
-          </a:p>
-          <a:p>
-            <a:pPr>
-              <a:buClr>
-                <a:srgbClr val="9E3611"/>
-              </a:buClr>
-            </a:pPr>
-            <a:endParaRPr lang="en-US" sz="2000" b="0" dirty="0"/>
+              <a:t>Base line, perfect consistency of graph</a:t>
+            </a:r>
           </a:p>
           <a:p>
             <a:pPr marL="0" indent="0">
@@ -7943,6 +8455,181 @@
     <p:extLst>
       <p:ext uri="{BB962C8B-B14F-4D97-AF65-F5344CB8AC3E}">
         <p14:creationId xmlns:p14="http://schemas.microsoft.com/office/powerpoint/2010/main" val="4193761839"/>
+      </p:ext>
+    </p:extLst>
+  </p:cSld>
+  <p:clrMapOvr>
+    <a:masterClrMapping/>
+  </p:clrMapOvr>
+</p:sld>
+</file>
+
+<file path=ppt/slides/slide8.xml><?xml version="1.0" encoding="utf-8"?>
+<p:sld xmlns:a="http://schemas.openxmlformats.org/drawingml/2006/main" xmlns:r="http://schemas.openxmlformats.org/officeDocument/2006/relationships" xmlns:p="http://schemas.openxmlformats.org/presentationml/2006/main">
+  <p:cSld>
+    <p:spTree>
+      <p:nvGrpSpPr>
+        <p:cNvPr id="1" name="">
+          <a:extLst>
+            <a:ext uri="{FF2B5EF4-FFF2-40B4-BE49-F238E27FC236}">
+              <a16:creationId xmlns:a16="http://schemas.microsoft.com/office/drawing/2014/main" id="{5AE726CA-0C73-DB6F-B294-0390FAAB0F12}"/>
+            </a:ext>
+          </a:extLst>
+        </p:cNvPr>
+        <p:cNvGrpSpPr/>
+        <p:nvPr/>
+      </p:nvGrpSpPr>
+      <p:grpSpPr>
+        <a:xfrm>
+          <a:off x="0" y="0"/>
+          <a:ext cx="0" cy="0"/>
+          <a:chOff x="0" y="0"/>
+          <a:chExt cx="0" cy="0"/>
+        </a:xfrm>
+      </p:grpSpPr>
+      <p:sp>
+        <p:nvSpPr>
+          <p:cNvPr id="3" name="Slide Number Placeholder 2">
+            <a:extLst>
+              <a:ext uri="{FF2B5EF4-FFF2-40B4-BE49-F238E27FC236}">
+                <a16:creationId xmlns:a16="http://schemas.microsoft.com/office/drawing/2014/main" id="{92C7D031-FCFC-5294-550C-4173DEE77689}"/>
+              </a:ext>
+            </a:extLst>
+          </p:cNvPr>
+          <p:cNvSpPr>
+            <a:spLocks noGrp="1"/>
+          </p:cNvSpPr>
+          <p:nvPr>
+            <p:ph type="sldNum" idx="1"/>
+          </p:nvPr>
+        </p:nvSpPr>
+        <p:spPr>
+          <a:xfrm>
+            <a:off x="9093107" y="4704588"/>
+            <a:ext cx="480060" cy="273844"/>
+          </a:xfrm>
+        </p:spPr>
+        <p:txBody>
+          <a:bodyPr/>
+          <a:lstStyle/>
+          <a:p>
+            <a:fld id="{7475F232-FFFE-5E6C-5554-2F165DAD28C0}" type="slidenum">
+              <a:rPr lang="en-JP" smtClean="0"/>
+              <a:t>8</a:t>
+            </a:fld>
+            <a:endParaRPr lang="en-JP" dirty="0"/>
+          </a:p>
+        </p:txBody>
+      </p:sp>
+      <p:sp>
+        <p:nvSpPr>
+          <p:cNvPr id="4" name="Title 3">
+            <a:extLst>
+              <a:ext uri="{FF2B5EF4-FFF2-40B4-BE49-F238E27FC236}">
+                <a16:creationId xmlns:a16="http://schemas.microsoft.com/office/drawing/2014/main" id="{56478381-4841-7228-4B1D-4F7BD3499DF0}"/>
+              </a:ext>
+            </a:extLst>
+          </p:cNvPr>
+          <p:cNvSpPr>
+            <a:spLocks noGrp="1"/>
+          </p:cNvSpPr>
+          <p:nvPr>
+            <p:ph type="title" idx="2"/>
+          </p:nvPr>
+        </p:nvSpPr>
+        <p:spPr/>
+        <p:txBody>
+          <a:bodyPr/>
+          <a:lstStyle/>
+          <a:p>
+            <a:pPr marL="0">
+              <a:buClr>
+                <a:srgbClr val="9E3611"/>
+              </a:buClr>
+            </a:pPr>
+            <a:r>
+              <a:rPr lang="en-US" sz="2400" dirty="0">
+                <a:ea typeface="游ゴシック Medium"/>
+                <a:cs typeface="Times New Roman"/>
+              </a:rPr>
+              <a:t>   What else?</a:t>
+            </a:r>
+          </a:p>
+        </p:txBody>
+      </p:sp>
+      <p:sp>
+        <p:nvSpPr>
+          <p:cNvPr id="16" name="Text Placeholder 1">
+            <a:extLst>
+              <a:ext uri="{FF2B5EF4-FFF2-40B4-BE49-F238E27FC236}">
+                <a16:creationId xmlns:a16="http://schemas.microsoft.com/office/drawing/2014/main" id="{321A1F38-7EB0-6CA7-732A-8A35F3AD5CB0}"/>
+              </a:ext>
+            </a:extLst>
+          </p:cNvPr>
+          <p:cNvSpPr>
+            <a:spLocks noGrp="1"/>
+          </p:cNvSpPr>
+          <p:nvPr>
+            <p:ph type="body"/>
+          </p:nvPr>
+        </p:nvSpPr>
+        <p:spPr>
+          <a:xfrm>
+            <a:off x="170325" y="707816"/>
+            <a:ext cx="8218099" cy="3986866"/>
+          </a:xfrm>
+        </p:spPr>
+        <p:txBody>
+          <a:bodyPr vert="horz" lIns="91440" tIns="45720" rIns="91440" bIns="45720" rtlCol="0" anchor="t">
+            <a:normAutofit/>
+          </a:bodyPr>
+          <a:lstStyle/>
+          <a:p>
+            <a:pPr>
+              <a:buClr>
+                <a:srgbClr val="9E3611"/>
+              </a:buClr>
+            </a:pPr>
+            <a:r>
+              <a:rPr lang="en-US" sz="2000" b="0" dirty="0"/>
+              <a:t>Writing Master thesis</a:t>
+            </a:r>
+          </a:p>
+          <a:p>
+            <a:pPr marL="0" indent="0">
+              <a:buClr>
+                <a:srgbClr val="9E3611"/>
+              </a:buClr>
+              <a:buNone/>
+            </a:pPr>
+            <a:endParaRPr lang="en-US" sz="2000" b="0" dirty="0"/>
+          </a:p>
+          <a:p>
+            <a:pPr>
+              <a:buClr>
+                <a:srgbClr val="9E3611"/>
+              </a:buClr>
+            </a:pPr>
+            <a:r>
+              <a:rPr lang="en-US" sz="2000" b="0" dirty="0"/>
+              <a:t>Reading</a:t>
+            </a:r>
+          </a:p>
+          <a:p>
+            <a:pPr marL="0" indent="0">
+              <a:buClr>
+                <a:srgbClr val="9E3611"/>
+              </a:buClr>
+              <a:buNone/>
+            </a:pPr>
+            <a:endParaRPr lang="en-US" sz="2000" b="0" dirty="0"/>
+          </a:p>
+        </p:txBody>
+      </p:sp>
+    </p:spTree>
+    <p:extLst>
+      <p:ext uri="{BB962C8B-B14F-4D97-AF65-F5344CB8AC3E}">
+        <p14:creationId xmlns:p14="http://schemas.microsoft.com/office/powerpoint/2010/main" val="3849738365"/>
       </p:ext>
     </p:extLst>
   </p:cSld>

</xml_diff>

<commit_message>
save results functionality for pgo
</commit_message>
<xml_diff>
--- a/documents/presentations/Jannis_Meyer_Presentation_01_06_2026.pptx
+++ b/documents/presentations/Jannis_Meyer_Presentation_01_06_2026.pptx
@@ -2324,7 +2324,7 @@
           <a:p>
             <a:fld id="{8664C608-40B1-4030-A28D-5B74BC98ADCE}" type="datetimeFigureOut">
               <a:rPr lang="en-US" dirty="0"/>
-              <a:t>6/2/2026</a:t>
+              <a:t>6/5/2026</a:t>
             </a:fld>
             <a:endParaRPr lang="en-US" dirty="0"/>
           </a:p>
@@ -7733,8 +7733,8 @@
           </a:p>
         </p:txBody>
       </p:sp>
-      <mc:AlternateContent xmlns:mc="http://schemas.openxmlformats.org/markup-compatibility/2006">
-        <mc:Choice xmlns:a14="http://schemas.microsoft.com/office/drawing/2010/main" Requires="a14">
+      <mc:AlternateContent xmlns:mc="http://schemas.openxmlformats.org/markup-compatibility/2006" xmlns:a14="http://schemas.microsoft.com/office/drawing/2010/main">
+        <mc:Choice Requires="a14">
           <p:sp>
             <p:nvSpPr>
               <p:cNvPr id="5" name="Text Placeholder 1">
@@ -9052,7 +9052,7 @@
             </p:txBody>
           </p:sp>
         </mc:Choice>
-        <mc:Fallback>
+        <mc:Fallback xmlns="">
           <p:sp>
             <p:nvSpPr>
               <p:cNvPr id="5" name="Text Placeholder 1">
@@ -10536,7 +10536,7 @@
           <p:nvPr>
             <p:extLst>
               <p:ext uri="{D42A27DB-BD31-4B8C-83A1-F6EECF244321}">
-                <p14:modId xmlns:p14="http://schemas.microsoft.com/office/powerpoint/2010/main" val="387835560"/>
+                <p14:modId xmlns:p14="http://schemas.microsoft.com/office/powerpoint/2010/main" val="3321014242"/>
               </p:ext>
             </p:extLst>
           </p:nvPr>
@@ -10730,7 +10730,7 @@
                     <a:p>
                       <a:r>
                         <a:rPr lang="en-US" dirty="0"/>
-                        <a:t>GPE: 4.9mm</a:t>
+                        <a:t>GPE: 4.92mm</a:t>
                       </a:r>
                     </a:p>
                     <a:p>
@@ -10782,7 +10782,7 @@
                           <a:ea typeface="+mn-ea"/>
                           <a:cs typeface="+mn-cs"/>
                         </a:rPr>
-                        <a:t>24.79mm</a:t>
+                        <a:t>24.51mm</a:t>
                       </a:r>
                     </a:p>
                   </a:txBody>
@@ -10817,7 +10817,7 @@
                     <a:p>
                       <a:r>
                         <a:rPr lang="en-US" dirty="0"/>
-                        <a:t>GPE: /</a:t>
+                        <a:t>GPE: 24.64mm</a:t>
                       </a:r>
                     </a:p>
                   </a:txBody>
@@ -10935,7 +10935,7 @@
                           <a:ea typeface="+mn-ea"/>
                           <a:cs typeface="+mn-cs"/>
                         </a:rPr>
-                        <a:t>GPE: 56.5mm</a:t>
+                        <a:t>GPE: 56.53mm</a:t>
                       </a:r>
                     </a:p>
                   </a:txBody>
@@ -10957,7 +10957,7 @@
                     <a:p>
                       <a:r>
                         <a:rPr lang="en-US" dirty="0"/>
-                        <a:t>GPE: 9.1mm</a:t>
+                        <a:t>GPE: 9.45mm</a:t>
                       </a:r>
                     </a:p>
                     <a:p>
@@ -10999,10 +10999,30 @@
                       <a:endParaRPr lang="en-US" dirty="0"/>
                     </a:p>
                     <a:p>
+                      <a:pPr marL="0" marR="0" lvl="0" indent="0" algn="l" defTabSz="685800" rtl="0" eaLnBrk="1" fontAlgn="auto" latinLnBrk="0" hangingPunct="1">
+                        <a:lnSpc>
+                          <a:spcPct val="100000"/>
+                        </a:lnSpc>
+                        <a:spcBef>
+                          <a:spcPts val="0"/>
+                        </a:spcBef>
+                        <a:spcAft>
+                          <a:spcPts val="0"/>
+                        </a:spcAft>
+                        <a:buClrTx/>
+                        <a:buSzTx/>
+                        <a:buFontTx/>
+                        <a:buNone/>
+                        <a:tabLst/>
+                        <a:defRPr/>
+                      </a:pPr>
                       <a:r>
                         <a:rPr lang="en-US" dirty="0"/>
-                        <a:t>GPE: /</a:t>
+                        <a:t>GPE: 9.43mm</a:t>
                       </a:r>
+                    </a:p>
+                    <a:p>
+                      <a:endParaRPr lang="en-US" dirty="0"/>
                     </a:p>
                   </a:txBody>
                   <a:tcPr/>
@@ -12401,12 +12421,64 @@
 </file>
 
 <file path=customXml/item1.xml><?xml version="1.0" encoding="utf-8"?>
-<?mso-contentType ?>
-<FormTemplates xmlns="http://schemas.microsoft.com/sharepoint/v3/contenttype/forms">
-  <Display>DocumentLibraryForm</Display>
-  <Edit>DocumentLibraryForm</Edit>
-  <New>DocumentLibraryForm</New>
-</FormTemplates>
+<p:properties xmlns:p="http://schemas.microsoft.com/office/2006/metadata/properties" xmlns:xsi="http://www.w3.org/2001/XMLSchema-instance" xmlns:pc="http://schemas.microsoft.com/office/infopath/2007/PartnerControls">
+  <documentManagement>
+    <TaxCatchAll xmlns="bbdc8989-56fb-4b1d-a38b-166581c893ff" xsi:nil="true"/>
+    <lcf76f155ced4ddcb4097134ff3c332f xmlns="f61654bb-b7fc-45ad-85e3-d08f7c4a7ee2">
+      <Terms xmlns="http://schemas.microsoft.com/office/infopath/2007/PartnerControls"/>
+    </lcf76f155ced4ddcb4097134ff3c332f>
+    <Title0 xmlns="f61654bb-b7fc-45ad-85e3-d08f7c4a7ee2" xsi:nil="true"/>
+    <Year xmlns="f61654bb-b7fc-45ad-85e3-d08f7c4a7ee2" xsi:nil="true"/>
+    <Author0 xmlns="f61654bb-b7fc-45ad-85e3-d08f7c4a7ee2" xsi:nil="true"/>
+    <Authors xmlns="f61654bb-b7fc-45ad-85e3-d08f7c4a7ee2" xsi:nil="true"/>
+    <NotebookType xmlns="f61654bb-b7fc-45ad-85e3-d08f7c4a7ee2" xsi:nil="true"/>
+    <Templates xmlns="f61654bb-b7fc-45ad-85e3-d08f7c4a7ee2" xsi:nil="true"/>
+    <AppVersion xmlns="f61654bb-b7fc-45ad-85e3-d08f7c4a7ee2" xsi:nil="true"/>
+    <IsNotebookLocked xmlns="f61654bb-b7fc-45ad-85e3-d08f7c4a7ee2" xsi:nil="true"/>
+    <Self_Registration_Enabled xmlns="f61654bb-b7fc-45ad-85e3-d08f7c4a7ee2" xsi:nil="true"/>
+    <Has_Leaders_Only_SectionGroup xmlns="f61654bb-b7fc-45ad-85e3-d08f7c4a7ee2" xsi:nil="true"/>
+    <Invited_Members xmlns="f61654bb-b7fc-45ad-85e3-d08f7c4a7ee2" xsi:nil="true"/>
+    <Is_Collaboration_Space_Locked xmlns="f61654bb-b7fc-45ad-85e3-d08f7c4a7ee2" xsi:nil="true"/>
+    <LMS_Mappings xmlns="f61654bb-b7fc-45ad-85e3-d08f7c4a7ee2" xsi:nil="true"/>
+    <Invited_Leaders xmlns="f61654bb-b7fc-45ad-85e3-d08f7c4a7ee2" xsi:nil="true"/>
+    <Math_Settings xmlns="f61654bb-b7fc-45ad-85e3-d08f7c4a7ee2" xsi:nil="true"/>
+    <Members xmlns="f61654bb-b7fc-45ad-85e3-d08f7c4a7ee2">
+      <UserInfo>
+        <DisplayName/>
+        <AccountId xsi:nil="true"/>
+        <AccountType/>
+      </UserInfo>
+    </Members>
+    <DefaultSectionNames xmlns="f61654bb-b7fc-45ad-85e3-d08f7c4a7ee2" xsi:nil="true"/>
+    <TeamsChannelId xmlns="f61654bb-b7fc-45ad-85e3-d08f7c4a7ee2" xsi:nil="true"/>
+    <FolderType xmlns="f61654bb-b7fc-45ad-85e3-d08f7c4a7ee2" xsi:nil="true"/>
+    <Leaders xmlns="f61654bb-b7fc-45ad-85e3-d08f7c4a7ee2">
+      <UserInfo>
+        <DisplayName/>
+        <AccountId xsi:nil="true"/>
+        <AccountType/>
+      </UserInfo>
+    </Leaders>
+    <Distribution_Groups xmlns="f61654bb-b7fc-45ad-85e3-d08f7c4a7ee2" xsi:nil="true"/>
+    <Member_Groups xmlns="f61654bb-b7fc-45ad-85e3-d08f7c4a7ee2">
+      <UserInfo>
+        <DisplayName/>
+        <AccountId xsi:nil="true"/>
+        <AccountType/>
+      </UserInfo>
+    </Member_Groups>
+    <Teams_Channel_Section_Location xmlns="f61654bb-b7fc-45ad-85e3-d08f7c4a7ee2" xsi:nil="true"/>
+    <CultureName xmlns="f61654bb-b7fc-45ad-85e3-d08f7c4a7ee2" xsi:nil="true"/>
+    <Owner xmlns="f61654bb-b7fc-45ad-85e3-d08f7c4a7ee2">
+      <UserInfo>
+        <DisplayName/>
+        <AccountId xsi:nil="true"/>
+        <AccountType/>
+      </UserInfo>
+    </Owner>
+    <_x30a2__x30c3__x30d7__x30ed__x30fc__x30c9__x65e5__x4ed8_ xmlns="f61654bb-b7fc-45ad-85e3-d08f7c4a7ee2" xsi:nil="true"/>
+  </documentManagement>
+</p:properties>
 </file>
 
 <file path=customXml/item2.xml><?xml version="1.0" encoding="utf-8"?>
@@ -12881,70 +12953,27 @@
 </file>
 
 <file path=customXml/item3.xml><?xml version="1.0" encoding="utf-8"?>
-<p:properties xmlns:p="http://schemas.microsoft.com/office/2006/metadata/properties" xmlns:xsi="http://www.w3.org/2001/XMLSchema-instance" xmlns:pc="http://schemas.microsoft.com/office/infopath/2007/PartnerControls">
-  <documentManagement>
-    <TaxCatchAll xmlns="bbdc8989-56fb-4b1d-a38b-166581c893ff" xsi:nil="true"/>
-    <lcf76f155ced4ddcb4097134ff3c332f xmlns="f61654bb-b7fc-45ad-85e3-d08f7c4a7ee2">
-      <Terms xmlns="http://schemas.microsoft.com/office/infopath/2007/PartnerControls"/>
-    </lcf76f155ced4ddcb4097134ff3c332f>
-    <Title0 xmlns="f61654bb-b7fc-45ad-85e3-d08f7c4a7ee2" xsi:nil="true"/>
-    <Year xmlns="f61654bb-b7fc-45ad-85e3-d08f7c4a7ee2" xsi:nil="true"/>
-    <Author0 xmlns="f61654bb-b7fc-45ad-85e3-d08f7c4a7ee2" xsi:nil="true"/>
-    <Authors xmlns="f61654bb-b7fc-45ad-85e3-d08f7c4a7ee2" xsi:nil="true"/>
-    <NotebookType xmlns="f61654bb-b7fc-45ad-85e3-d08f7c4a7ee2" xsi:nil="true"/>
-    <Templates xmlns="f61654bb-b7fc-45ad-85e3-d08f7c4a7ee2" xsi:nil="true"/>
-    <AppVersion xmlns="f61654bb-b7fc-45ad-85e3-d08f7c4a7ee2" xsi:nil="true"/>
-    <IsNotebookLocked xmlns="f61654bb-b7fc-45ad-85e3-d08f7c4a7ee2" xsi:nil="true"/>
-    <Self_Registration_Enabled xmlns="f61654bb-b7fc-45ad-85e3-d08f7c4a7ee2" xsi:nil="true"/>
-    <Has_Leaders_Only_SectionGroup xmlns="f61654bb-b7fc-45ad-85e3-d08f7c4a7ee2" xsi:nil="true"/>
-    <Invited_Members xmlns="f61654bb-b7fc-45ad-85e3-d08f7c4a7ee2" xsi:nil="true"/>
-    <Is_Collaboration_Space_Locked xmlns="f61654bb-b7fc-45ad-85e3-d08f7c4a7ee2" xsi:nil="true"/>
-    <LMS_Mappings xmlns="f61654bb-b7fc-45ad-85e3-d08f7c4a7ee2" xsi:nil="true"/>
-    <Invited_Leaders xmlns="f61654bb-b7fc-45ad-85e3-d08f7c4a7ee2" xsi:nil="true"/>
-    <Math_Settings xmlns="f61654bb-b7fc-45ad-85e3-d08f7c4a7ee2" xsi:nil="true"/>
-    <Members xmlns="f61654bb-b7fc-45ad-85e3-d08f7c4a7ee2">
-      <UserInfo>
-        <DisplayName/>
-        <AccountId xsi:nil="true"/>
-        <AccountType/>
-      </UserInfo>
-    </Members>
-    <DefaultSectionNames xmlns="f61654bb-b7fc-45ad-85e3-d08f7c4a7ee2" xsi:nil="true"/>
-    <TeamsChannelId xmlns="f61654bb-b7fc-45ad-85e3-d08f7c4a7ee2" xsi:nil="true"/>
-    <FolderType xmlns="f61654bb-b7fc-45ad-85e3-d08f7c4a7ee2" xsi:nil="true"/>
-    <Leaders xmlns="f61654bb-b7fc-45ad-85e3-d08f7c4a7ee2">
-      <UserInfo>
-        <DisplayName/>
-        <AccountId xsi:nil="true"/>
-        <AccountType/>
-      </UserInfo>
-    </Leaders>
-    <Distribution_Groups xmlns="f61654bb-b7fc-45ad-85e3-d08f7c4a7ee2" xsi:nil="true"/>
-    <Member_Groups xmlns="f61654bb-b7fc-45ad-85e3-d08f7c4a7ee2">
-      <UserInfo>
-        <DisplayName/>
-        <AccountId xsi:nil="true"/>
-        <AccountType/>
-      </UserInfo>
-    </Member_Groups>
-    <Teams_Channel_Section_Location xmlns="f61654bb-b7fc-45ad-85e3-d08f7c4a7ee2" xsi:nil="true"/>
-    <CultureName xmlns="f61654bb-b7fc-45ad-85e3-d08f7c4a7ee2" xsi:nil="true"/>
-    <Owner xmlns="f61654bb-b7fc-45ad-85e3-d08f7c4a7ee2">
-      <UserInfo>
-        <DisplayName/>
-        <AccountId xsi:nil="true"/>
-        <AccountType/>
-      </UserInfo>
-    </Owner>
-    <_x30a2__x30c3__x30d7__x30ed__x30fc__x30c9__x65e5__x4ed8_ xmlns="f61654bb-b7fc-45ad-85e3-d08f7c4a7ee2" xsi:nil="true"/>
-  </documentManagement>
-</p:properties>
+<?mso-contentType ?>
+<FormTemplates xmlns="http://schemas.microsoft.com/sharepoint/v3/contenttype/forms">
+  <Display>DocumentLibraryForm</Display>
+  <Edit>DocumentLibraryForm</Edit>
+  <New>DocumentLibraryForm</New>
+</FormTemplates>
 </file>
 
 <file path=customXml/itemProps1.xml><?xml version="1.0" encoding="utf-8"?>
-<ds:datastoreItem xmlns:ds="http://schemas.openxmlformats.org/officeDocument/2006/customXml" ds:itemID="{0A8BCAEC-5EDD-4F8B-8062-E645C37DABB6}">
+<ds:datastoreItem xmlns:ds="http://schemas.openxmlformats.org/officeDocument/2006/customXml" ds:itemID="{726A834E-B1B5-46FD-BC6A-86110B9E53A8}">
   <ds:schemaRefs>
-    <ds:schemaRef ds:uri="http://schemas.microsoft.com/sharepoint/v3/contenttype/forms"/>
+    <ds:schemaRef ds:uri="f61654bb-b7fc-45ad-85e3-d08f7c4a7ee2"/>
+    <ds:schemaRef ds:uri="http://schemas.microsoft.com/office/infopath/2007/PartnerControls"/>
+    <ds:schemaRef ds:uri="http://purl.org/dc/dcmitype/"/>
+    <ds:schemaRef ds:uri="http://purl.org/dc/elements/1.1/"/>
+    <ds:schemaRef ds:uri="bbdc8989-56fb-4b1d-a38b-166581c893ff"/>
+    <ds:schemaRef ds:uri="http://purl.org/dc/terms/"/>
+    <ds:schemaRef ds:uri="http://schemas.microsoft.com/office/2006/documentManagement/types"/>
+    <ds:schemaRef ds:uri="http://www.w3.org/XML/1998/namespace"/>
+    <ds:schemaRef ds:uri="http://schemas.openxmlformats.org/package/2006/metadata/core-properties"/>
+    <ds:schemaRef ds:uri="http://schemas.microsoft.com/office/2006/metadata/properties"/>
   </ds:schemaRefs>
 </ds:datastoreItem>
 </file>
@@ -12969,18 +12998,9 @@
 </file>
 
 <file path=customXml/itemProps3.xml><?xml version="1.0" encoding="utf-8"?>
-<ds:datastoreItem xmlns:ds="http://schemas.openxmlformats.org/officeDocument/2006/customXml" ds:itemID="{726A834E-B1B5-46FD-BC6A-86110B9E53A8}">
+<ds:datastoreItem xmlns:ds="http://schemas.openxmlformats.org/officeDocument/2006/customXml" ds:itemID="{0A8BCAEC-5EDD-4F8B-8062-E645C37DABB6}">
   <ds:schemaRefs>
-    <ds:schemaRef ds:uri="f61654bb-b7fc-45ad-85e3-d08f7c4a7ee2"/>
-    <ds:schemaRef ds:uri="http://schemas.microsoft.com/office/infopath/2007/PartnerControls"/>
-    <ds:schemaRef ds:uri="http://purl.org/dc/dcmitype/"/>
-    <ds:schemaRef ds:uri="http://purl.org/dc/elements/1.1/"/>
-    <ds:schemaRef ds:uri="bbdc8989-56fb-4b1d-a38b-166581c893ff"/>
-    <ds:schemaRef ds:uri="http://purl.org/dc/terms/"/>
-    <ds:schemaRef ds:uri="http://schemas.microsoft.com/office/2006/documentManagement/types"/>
-    <ds:schemaRef ds:uri="http://www.w3.org/XML/1998/namespace"/>
-    <ds:schemaRef ds:uri="http://schemas.openxmlformats.org/package/2006/metadata/core-properties"/>
-    <ds:schemaRef ds:uri="http://schemas.microsoft.com/office/2006/metadata/properties"/>
+    <ds:schemaRef ds:uri="http://schemas.microsoft.com/sharepoint/v3/contenttype/forms"/>
   </ds:schemaRefs>
 </ds:datastoreItem>
 </file>
</xml_diff>